<commit_message>
v0.6.0 - Implement MIR Section 2 manpower export
</commit_message>
<xml_diff>
--- a/scripts/spike-output/CREDO-MCI-WEST-Monthly-Impact-Report-June-2026.pptx
+++ b/scripts/spike-output/CREDO-MCI-WEST-Monthly-Impact-Report-June-2026.pptx
@@ -7660,7 +7660,7 @@
                   <a:srgbClr val="061B44"/>
                 </a:solidFill>
               </a:rPr>
-              <a:t>[Name]</a:t>
+              <a:t>LCDR Jane Smith</a:t>
             </a:r>
           </a:p>
         </p:txBody>
@@ -7700,7 +7700,7 @@
                   <a:srgbClr val="5B6778"/>
                 </a:solidFill>
               </a:rPr>
-              <a:t>[Title]</a:t>
+              <a:t>CREDO Director</a:t>
             </a:r>
           </a:p>
         </p:txBody>
@@ -7740,7 +7740,7 @@
                   <a:srgbClr val="061B44"/>
                 </a:solidFill>
               </a:rPr>
-              <a:t>[Role]</a:t>
+              <a:t>Onboard / Lead Q3 planning</a:t>
             </a:r>
           </a:p>
         </p:txBody>
@@ -7780,7 +7780,7 @@
                   <a:srgbClr val="5B6778"/>
                 </a:solidFill>
               </a:rPr>
-              <a:t>[Date]</a:t>
+              <a:t>DEC 2027</a:t>
             </a:r>
           </a:p>
         </p:txBody>
@@ -7932,7 +7932,7 @@
                   <a:srgbClr val="061B44"/>
                 </a:solidFill>
               </a:rPr>
-              <a:t>[Name]</a:t>
+              <a:t>LT Marcus Chen</a:t>
             </a:r>
           </a:p>
         </p:txBody>
@@ -7972,7 +7972,7 @@
                   <a:srgbClr val="5B6778"/>
                 </a:solidFill>
               </a:rPr>
-              <a:t>[Title]</a:t>
+              <a:t>Deputy Director</a:t>
             </a:r>
           </a:p>
         </p:txBody>
@@ -8012,7 +8012,7 @@
                   <a:srgbClr val="061B44"/>
                 </a:solidFill>
               </a:rPr>
-              <a:t>[Role]</a:t>
+              <a:t>PCS prep / Handoff brief</a:t>
             </a:r>
           </a:p>
         </p:txBody>
@@ -8052,7 +8052,7 @@
                   <a:srgbClr val="5B6778"/>
                 </a:solidFill>
               </a:rPr>
-              <a:t>[Date]</a:t>
+              <a:t>JUN 2026</a:t>
             </a:r>
           </a:p>
         </p:txBody>
@@ -8204,7 +8204,7 @@
                   <a:srgbClr val="061B44"/>
                 </a:solidFill>
               </a:rPr>
-              <a:t>[Name]</a:t>
+              <a:t>HMCS Alex Rivera</a:t>
             </a:r>
           </a:p>
         </p:txBody>
@@ -8244,7 +8244,7 @@
                   <a:srgbClr val="5B6778"/>
                 </a:solidFill>
               </a:rPr>
-              <a:t>[Title]</a:t>
+              <a:t>Admin Lead</a:t>
             </a:r>
           </a:p>
         </p:txBody>
@@ -8284,7 +8284,7 @@
                   <a:srgbClr val="061B44"/>
                 </a:solidFill>
               </a:rPr>
-              <a:t>[Role]</a:t>
+              <a:t>Active / Training pipeline</a:t>
             </a:r>
           </a:p>
         </p:txBody>
@@ -8324,7 +8324,7 @@
                   <a:srgbClr val="5B6778"/>
                 </a:solidFill>
               </a:rPr>
-              <a:t>[Date]</a:t>
+              <a:t>MAR 2028</a:t>
             </a:r>
           </a:p>
         </p:txBody>
@@ -8476,7 +8476,7 @@
                   <a:srgbClr val="061B44"/>
                 </a:solidFill>
               </a:rPr>
-              <a:t>[Name]</a:t>
+              <a:t/>
             </a:r>
           </a:p>
         </p:txBody>
@@ -8516,7 +8516,7 @@
                   <a:srgbClr val="5B6778"/>
                 </a:solidFill>
               </a:rPr>
-              <a:t>[Title]</a:t>
+              <a:t/>
             </a:r>
           </a:p>
         </p:txBody>
@@ -8556,7 +8556,7 @@
                   <a:srgbClr val="061B44"/>
                 </a:solidFill>
               </a:rPr>
-              <a:t>[Role]</a:t>
+              <a:t/>
             </a:r>
           </a:p>
         </p:txBody>
@@ -8596,7 +8596,7 @@
                   <a:srgbClr val="5B6778"/>
                 </a:solidFill>
               </a:rPr>
-              <a:t>[Date]</a:t>
+              <a:t/>
             </a:r>
           </a:p>
         </p:txBody>
@@ -8748,7 +8748,7 @@
                   <a:srgbClr val="061B44"/>
                 </a:solidFill>
               </a:rPr>
-              <a:t>[Name]</a:t>
+              <a:t/>
             </a:r>
           </a:p>
         </p:txBody>
@@ -8788,7 +8788,7 @@
                   <a:srgbClr val="5B6778"/>
                 </a:solidFill>
               </a:rPr>
-              <a:t>[Title]</a:t>
+              <a:t/>
             </a:r>
           </a:p>
         </p:txBody>
@@ -8828,7 +8828,7 @@
                   <a:srgbClr val="061B44"/>
                 </a:solidFill>
               </a:rPr>
-              <a:t>[Role]</a:t>
+              <a:t/>
             </a:r>
           </a:p>
         </p:txBody>
@@ -8868,7 +8868,7 @@
                   <a:srgbClr val="5B6778"/>
                 </a:solidFill>
               </a:rPr>
-              <a:t>[Date]</a:t>
+              <a:t/>
             </a:r>
           </a:p>
         </p:txBody>

</xml_diff>